<commit_message>
minor tweak to trigger deploy
</commit_message>
<xml_diff>
--- a/Slides/Module 02 Test-Driven Development.pptx
+++ b/Slides/Module 02 Test-Driven Development.pptx
@@ -283,7 +283,7 @@
           <a:p>
             <a:fld id="{7C7E5181-6CF5-45F7-A87A-E0E0B1FD7549}" type="datetimeFigureOut">
               <a:rPr lang="en-US" smtClean="0"/>
-              <a:t>7/8/2026</a:t>
+              <a:t>8/17/2026</a:t>
             </a:fld>
             <a:endParaRPr lang="en-US"/>
           </a:p>
@@ -3777,7 +3777,7 @@
           <a:p>
             <a:fld id="{5D2A64DE-480B-420F-9649-4F8E696E08E0}" type="datetime1">
               <a:rPr lang="en-US" smtClean="0"/>
-              <a:t>7/8/2026</a:t>
+              <a:t>8/17/2026</a:t>
             </a:fld>
             <a:endParaRPr lang="en-US"/>
           </a:p>
@@ -4101,7 +4101,7 @@
           <a:p>
             <a:fld id="{EA476A42-A091-4468-A075-64A31BE59948}" type="datetime1">
               <a:rPr lang="en-US" smtClean="0"/>
-              <a:t>7/8/2026</a:t>
+              <a:t>8/17/2026</a:t>
             </a:fld>
             <a:endParaRPr lang="en-US"/>
           </a:p>
@@ -4299,7 +4299,7 @@
           <a:p>
             <a:fld id="{0D3616D0-8311-4107-9726-6B805E7D05BA}" type="datetime1">
               <a:rPr lang="en-US" smtClean="0"/>
-              <a:t>7/8/2026</a:t>
+              <a:t>8/17/2026</a:t>
             </a:fld>
             <a:endParaRPr lang="en-US"/>
           </a:p>
@@ -4507,7 +4507,7 @@
           <a:p>
             <a:fld id="{3BC2557A-5C88-417A-A763-5AC779462A5F}" type="datetime1">
               <a:rPr lang="en-US" smtClean="0"/>
-              <a:t>7/8/2026</a:t>
+              <a:t>8/17/2026</a:t>
             </a:fld>
             <a:endParaRPr lang="en-US"/>
           </a:p>
@@ -4929,7 +4929,7 @@
           <a:p>
             <a:fld id="{07C7BFD4-467E-4EDE-93EA-052F5B39A4E5}" type="datetime1">
               <a:rPr lang="en-US" smtClean="0"/>
-              <a:t>7/8/2026</a:t>
+              <a:t>8/17/2026</a:t>
             </a:fld>
             <a:endParaRPr lang="en-US"/>
           </a:p>
@@ -5179,7 +5179,7 @@
           <a:p>
             <a:fld id="{07C7BFD4-467E-4EDE-93EA-052F5B39A4E5}" type="datetime1">
               <a:rPr lang="en-US" smtClean="0"/>
-              <a:t>7/8/2026</a:t>
+              <a:t>8/17/2026</a:t>
             </a:fld>
             <a:endParaRPr lang="en-US"/>
           </a:p>
@@ -5361,7 +5361,7 @@
           <a:p>
             <a:fld id="{109E55A0-C911-4F03-82FC-7E5926047D46}" type="datetime1">
               <a:rPr lang="en-US" smtClean="0"/>
-              <a:t>7/8/2026</a:t>
+              <a:t>8/17/2026</a:t>
             </a:fld>
             <a:endParaRPr lang="en-US"/>
           </a:p>
@@ -5674,7 +5674,7 @@
           <a:p>
             <a:fld id="{A533CBE2-D5BE-47AC-ADC2-9CDFC1D0CF90}" type="datetime1">
               <a:rPr lang="en-US" smtClean="0"/>
-              <a:t>7/8/2026</a:t>
+              <a:t>8/17/2026</a:t>
             </a:fld>
             <a:endParaRPr lang="en-US"/>
           </a:p>
@@ -5975,7 +5975,7 @@
           <a:p>
             <a:fld id="{39B7EDB1-CE74-4951-85A2-0B01C2128E28}" type="datetime1">
               <a:rPr lang="en-US" smtClean="0"/>
-              <a:t>7/8/2026</a:t>
+              <a:t>8/17/2026</a:t>
             </a:fld>
             <a:endParaRPr lang="en-US"/>
           </a:p>
@@ -6423,7 +6423,7 @@
           <a:p>
             <a:fld id="{2BC7EB92-A5C2-4807-A9DC-9EDE6CBFB241}" type="datetime1">
               <a:rPr lang="en-US" smtClean="0"/>
-              <a:t>7/8/2026</a:t>
+              <a:t>8/17/2026</a:t>
             </a:fld>
             <a:endParaRPr lang="en-US"/>
           </a:p>
@@ -6536,7 +6536,7 @@
           <a:p>
             <a:fld id="{2B7B7EE0-7771-4CD5-9B2B-3550753A54A1}" type="datetime1">
               <a:rPr lang="en-US" smtClean="0"/>
-              <a:t>7/8/2026</a:t>
+              <a:t>8/17/2026</a:t>
             </a:fld>
             <a:endParaRPr lang="en-US"/>
           </a:p>
@@ -6847,7 +6847,7 @@
           <a:p>
             <a:fld id="{F8B318B3-0E87-4416-A9B8-D891968C2727}" type="datetime1">
               <a:rPr lang="en-US" smtClean="0"/>
-              <a:t>7/8/2026</a:t>
+              <a:t>8/17/2026</a:t>
             </a:fld>
             <a:endParaRPr lang="en-US"/>
           </a:p>
@@ -7088,7 +7088,7 @@
           <a:p>
             <a:fld id="{54D997E8-DDEE-43F1-8D9B-F8A1E11DE488}" type="datetime1">
               <a:rPr lang="en-US" smtClean="0"/>
-              <a:t>7/8/2026</a:t>
+              <a:t>8/17/2026</a:t>
             </a:fld>
             <a:endParaRPr lang="en-US"/>
           </a:p>
@@ -19534,8 +19534,13 @@
             <a:pPr lvl="1"/>
             <a:r>
               <a:rPr lang="en-US" dirty="0"/>
-              <a:t>Explain the basics of Test-Driven Development</a:t>
-            </a:r>
+              <a:t>Explain the basics of </a:t>
+            </a:r>
+            <a:r>
+              <a:rPr lang="en-US"/>
+              <a:t>Test-Driven Development (TDD)</a:t>
+            </a:r>
+            <a:endParaRPr lang="en-US" dirty="0"/>
           </a:p>
           <a:p>
             <a:pPr lvl="1"/>

</xml_diff>

<commit_message>
adding a statement about design for testing
</commit_message>
<xml_diff>
--- a/Slides/Module 02 Test-Driven Development.pptx
+++ b/Slides/Module 02 Test-Driven Development.pptx
@@ -31614,7 +31614,7 @@
             <a:pPr lvl="1"/>
             <a:r>
               <a:rPr lang="en-US" altLang="en-US" dirty="0"/>
-              <a:t>Understands that deployment comes when the system passes testing </a:t>
+              <a:t>Understands that deployment comes when the system passes testing</a:t>
             </a:r>
           </a:p>
           <a:p>
@@ -31770,7 +31770,7 @@
         </p:nvGrpSpPr>
         <p:grpSpPr>
           <a:xfrm>
-            <a:off x="156796" y="2293785"/>
+            <a:off x="223057" y="1790203"/>
             <a:ext cx="11321493" cy="1904613"/>
             <a:chOff x="133350" y="1652027"/>
             <a:chExt cx="11321493" cy="1904613"/>
@@ -32409,7 +32409,7 @@
         </p:nvGrpSpPr>
         <p:grpSpPr>
           <a:xfrm>
-            <a:off x="1686135" y="3700308"/>
+            <a:off x="1752396" y="3196726"/>
             <a:ext cx="2190750" cy="1620693"/>
             <a:chOff x="1694164" y="3678445"/>
             <a:chExt cx="2190750" cy="1620693"/>
@@ -32552,7 +32552,7 @@
         </p:nvGrpSpPr>
         <p:grpSpPr>
           <a:xfrm>
-            <a:off x="4797844" y="3637260"/>
+            <a:off x="4864105" y="3133678"/>
             <a:ext cx="2190750" cy="1620693"/>
             <a:chOff x="1694164" y="3678445"/>
             <a:chExt cx="2190750" cy="1620693"/>
@@ -32681,6 +32681,213 @@
           </p:txBody>
         </p:sp>
       </p:grpSp>
+      <p:sp>
+        <p:nvSpPr>
+          <p:cNvPr id="20" name="Content Placeholder 2">
+            <a:extLst>
+              <a:ext uri="{FF2B5EF4-FFF2-40B4-BE49-F238E27FC236}">
+                <a16:creationId xmlns:a16="http://schemas.microsoft.com/office/drawing/2014/main" id="{A55221E7-F1EA-8CB1-657B-4272EB8B237D}"/>
+              </a:ext>
+            </a:extLst>
+          </p:cNvPr>
+          <p:cNvSpPr txBox="1">
+            <a:spLocks/>
+          </p:cNvSpPr>
+          <p:nvPr/>
+        </p:nvSpPr>
+        <p:spPr>
+          <a:xfrm>
+            <a:off x="838200" y="5280454"/>
+            <a:ext cx="9763539" cy="1075896"/>
+          </a:xfrm>
+          <a:prstGeom prst="rect">
+            <a:avLst/>
+          </a:prstGeom>
+        </p:spPr>
+        <p:txBody>
+          <a:bodyPr>
+            <a:normAutofit/>
+          </a:bodyPr>
+          <a:lstStyle>
+            <a:lvl1pPr marL="228600" indent="-228600" algn="l" defTabSz="914400" rtl="0" eaLnBrk="1" latinLnBrk="0" hangingPunct="1">
+              <a:lnSpc>
+                <a:spcPct val="100000"/>
+              </a:lnSpc>
+              <a:spcBef>
+                <a:spcPts val="1000"/>
+              </a:spcBef>
+              <a:buFont typeface="Arial" panose="020B0604020202020204" pitchFamily="34" charset="0"/>
+              <a:buChar char="•"/>
+              <a:defRPr sz="2800" kern="1200">
+                <a:solidFill>
+                  <a:schemeClr val="tx1"/>
+                </a:solidFill>
+                <a:latin typeface="+mn-lt"/>
+                <a:ea typeface="+mn-ea"/>
+                <a:cs typeface="+mn-cs"/>
+              </a:defRPr>
+            </a:lvl1pPr>
+            <a:lvl2pPr marL="685800" indent="-228600" algn="l" defTabSz="914400" rtl="0" eaLnBrk="1" latinLnBrk="0" hangingPunct="1">
+              <a:lnSpc>
+                <a:spcPct val="100000"/>
+              </a:lnSpc>
+              <a:spcBef>
+                <a:spcPts val="500"/>
+              </a:spcBef>
+              <a:buFont typeface="Arial" panose="020B0604020202020204" pitchFamily="34" charset="0"/>
+              <a:buChar char="•"/>
+              <a:defRPr sz="2400" kern="1200">
+                <a:solidFill>
+                  <a:schemeClr val="tx1"/>
+                </a:solidFill>
+                <a:latin typeface="+mn-lt"/>
+                <a:ea typeface="+mn-ea"/>
+                <a:cs typeface="+mn-cs"/>
+              </a:defRPr>
+            </a:lvl2pPr>
+            <a:lvl3pPr marL="1143000" indent="-228600" algn="l" defTabSz="914400" rtl="0" eaLnBrk="1" latinLnBrk="0" hangingPunct="1">
+              <a:lnSpc>
+                <a:spcPct val="100000"/>
+              </a:lnSpc>
+              <a:spcBef>
+                <a:spcPts val="500"/>
+              </a:spcBef>
+              <a:buFont typeface="Arial" panose="020B0604020202020204" pitchFamily="34" charset="0"/>
+              <a:buChar char="•"/>
+              <a:defRPr sz="2000" kern="1200">
+                <a:solidFill>
+                  <a:schemeClr val="tx1"/>
+                </a:solidFill>
+                <a:latin typeface="+mn-lt"/>
+                <a:ea typeface="+mn-ea"/>
+                <a:cs typeface="+mn-cs"/>
+              </a:defRPr>
+            </a:lvl3pPr>
+            <a:lvl4pPr marL="1600200" indent="-228600" algn="l" defTabSz="914400" rtl="0" eaLnBrk="1" latinLnBrk="0" hangingPunct="1">
+              <a:lnSpc>
+                <a:spcPct val="100000"/>
+              </a:lnSpc>
+              <a:spcBef>
+                <a:spcPts val="500"/>
+              </a:spcBef>
+              <a:buFont typeface="Arial" panose="020B0604020202020204" pitchFamily="34" charset="0"/>
+              <a:buChar char="•"/>
+              <a:defRPr sz="1800" kern="1200">
+                <a:solidFill>
+                  <a:schemeClr val="tx1"/>
+                </a:solidFill>
+                <a:latin typeface="+mn-lt"/>
+                <a:ea typeface="+mn-ea"/>
+                <a:cs typeface="+mn-cs"/>
+              </a:defRPr>
+            </a:lvl4pPr>
+            <a:lvl5pPr marL="2057400" indent="-228600" algn="l" defTabSz="914400" rtl="0" eaLnBrk="1" latinLnBrk="0" hangingPunct="1">
+              <a:lnSpc>
+                <a:spcPct val="100000"/>
+              </a:lnSpc>
+              <a:spcBef>
+                <a:spcPts val="500"/>
+              </a:spcBef>
+              <a:buFont typeface="Arial" panose="020B0604020202020204" pitchFamily="34" charset="0"/>
+              <a:buChar char="•"/>
+              <a:defRPr sz="1800" kern="1200">
+                <a:solidFill>
+                  <a:schemeClr val="tx1"/>
+                </a:solidFill>
+                <a:latin typeface="+mn-lt"/>
+                <a:ea typeface="+mn-ea"/>
+                <a:cs typeface="+mn-cs"/>
+              </a:defRPr>
+            </a:lvl5pPr>
+            <a:lvl6pPr marL="2514600" indent="-228600" algn="l" defTabSz="914400" rtl="0" eaLnBrk="1" latinLnBrk="0" hangingPunct="1">
+              <a:lnSpc>
+                <a:spcPct val="90000"/>
+              </a:lnSpc>
+              <a:spcBef>
+                <a:spcPts val="500"/>
+              </a:spcBef>
+              <a:buFont typeface="Arial" panose="020B0604020202020204" pitchFamily="34" charset="0"/>
+              <a:buChar char="•"/>
+              <a:defRPr sz="1800" kern="1200">
+                <a:solidFill>
+                  <a:schemeClr val="tx1"/>
+                </a:solidFill>
+                <a:latin typeface="+mn-lt"/>
+                <a:ea typeface="+mn-ea"/>
+                <a:cs typeface="+mn-cs"/>
+              </a:defRPr>
+            </a:lvl6pPr>
+            <a:lvl7pPr marL="2971800" indent="-228600" algn="l" defTabSz="914400" rtl="0" eaLnBrk="1" latinLnBrk="0" hangingPunct="1">
+              <a:lnSpc>
+                <a:spcPct val="90000"/>
+              </a:lnSpc>
+              <a:spcBef>
+                <a:spcPts val="500"/>
+              </a:spcBef>
+              <a:buFont typeface="Arial" panose="020B0604020202020204" pitchFamily="34" charset="0"/>
+              <a:buChar char="•"/>
+              <a:defRPr sz="1800" kern="1200">
+                <a:solidFill>
+                  <a:schemeClr val="tx1"/>
+                </a:solidFill>
+                <a:latin typeface="+mn-lt"/>
+                <a:ea typeface="+mn-ea"/>
+                <a:cs typeface="+mn-cs"/>
+              </a:defRPr>
+            </a:lvl7pPr>
+            <a:lvl8pPr marL="3429000" indent="-228600" algn="l" defTabSz="914400" rtl="0" eaLnBrk="1" latinLnBrk="0" hangingPunct="1">
+              <a:lnSpc>
+                <a:spcPct val="90000"/>
+              </a:lnSpc>
+              <a:spcBef>
+                <a:spcPts val="500"/>
+              </a:spcBef>
+              <a:buFont typeface="Arial" panose="020B0604020202020204" pitchFamily="34" charset="0"/>
+              <a:buChar char="•"/>
+              <a:defRPr sz="1800" kern="1200">
+                <a:solidFill>
+                  <a:schemeClr val="tx1"/>
+                </a:solidFill>
+                <a:latin typeface="+mn-lt"/>
+                <a:ea typeface="+mn-ea"/>
+                <a:cs typeface="+mn-cs"/>
+              </a:defRPr>
+            </a:lvl8pPr>
+            <a:lvl9pPr marL="3886200" indent="-228600" algn="l" defTabSz="914400" rtl="0" eaLnBrk="1" latinLnBrk="0" hangingPunct="1">
+              <a:lnSpc>
+                <a:spcPct val="90000"/>
+              </a:lnSpc>
+              <a:spcBef>
+                <a:spcPts val="500"/>
+              </a:spcBef>
+              <a:buFont typeface="Arial" panose="020B0604020202020204" pitchFamily="34" charset="0"/>
+              <a:buChar char="•"/>
+              <a:defRPr sz="1800" kern="1200">
+                <a:solidFill>
+                  <a:schemeClr val="tx1"/>
+                </a:solidFill>
+                <a:latin typeface="+mn-lt"/>
+                <a:ea typeface="+mn-ea"/>
+                <a:cs typeface="+mn-cs"/>
+              </a:defRPr>
+            </a:lvl9pPr>
+          </a:lstStyle>
+          <a:p>
+            <a:pPr marL="0" indent="0">
+              <a:buNone/>
+            </a:pPr>
+            <a:r>
+              <a:rPr lang="en-US" b="1" i="1" dirty="0"/>
+              <a:t>Design for Testing </a:t>
+            </a:r>
+            <a:r>
+              <a:rPr lang="en-US" dirty="0"/>
+              <a:t>means that you are building your architecture and code so that they are easy to test, monitor, and debug!</a:t>
+            </a:r>
+            <a:endParaRPr lang="en-US" altLang="en-US" dirty="0"/>
+          </a:p>
+        </p:txBody>
+      </p:sp>
     </p:spTree>
     <p:extLst>
       <p:ext uri="{BB962C8B-B14F-4D97-AF65-F5344CB8AC3E}">

</xml_diff>